<commit_message>
refactor: cross_layer_method_framework 重构——写回降级为 guardrail，新增多模态泛化验证
- 第三张 workload 卡从 AI_FILTER/CLASSIFY 改为多模态图像理解
- 第三张策略卡从端到端验证：耦合与写回改为多模态泛化验证
- 删除独立写回卡片，降为两行 guardrail 注释
- 新增算子代价估计（补充讨论）注释
- 箭头改为线条+三角头
- 指标改为 GPU util + MFU 并存
- PPT 时间线第四阶段改为多模态泛化验证
- 画布 1000→880px
</commit_message>
<xml_diff>
--- a/opening/slides/opening_defense_20260720_v4.pptx
+++ b/opening/slides/opening_defense_20260720_v4.pptx
@@ -2416,7 +2416,7 @@
           <a:p/>
           <a:p>
             <a:pPr>
-              <a:defRPr sz="1100" b="1"/>
+              <a:defRPr b="1" sz="1100"/>
             </a:pPr>
             <a:r>
               <a:t>汇报讲稿：</a:t>
@@ -2424,20 +2424,20 @@
           </a:p>
           <a:p>
             <a:pPr>
-              <a:defRPr sz="1000" b="0"/>
-            </a:pPr>
-            <a:r>
-              <a:t>实验分四阶段。前置已全部完成。后续按数据组织→提交控制→耦合验证→写回判定顺序推进，每阶段有明确对照和反证。</a:t>
-            </a:r>
-          </a:p>
-          <a:p>
-            <a:pPr>
-              <a:defRPr sz="1100" b="0"/>
-            </a:pPr>
-          </a:p>
-          <a:p>
-            <a:pPr>
-              <a:defRPr sz="1100" b="1"/>
+              <a:defRPr sz="1000"/>
+            </a:pPr>
+            <a:r>
+              <a:t>实验分四阶段。前置已全部完成。后续按数据组织→提交控制→耦合验证顺序推进。多模态泛化验证为正文实验(§5.3)，写回作为 guardrail，算子代价估计为补充讨论。每阶段有明确对照和反证。</a:t>
+            </a:r>
+          </a:p>
+          <a:p>
+            <a:pPr>
+              <a:defRPr sz="1100"/>
+            </a:pPr>
+          </a:p>
+          <a:p>
+            <a:pPr>
+              <a:defRPr b="1" sz="1100"/>
             </a:pPr>
             <a:r>
               <a:t>答辩备注：</a:t>
@@ -2445,10 +2445,10 @@
           </a:p>
           <a:p>
             <a:pPr>
-              <a:defRPr sz="1000" b="0"/>
-            </a:pPr>
-            <a:r>
-              <a:t>前置完成证明方案可执行。如被问'4个月能否完成'：前置已满足，每阶段实验规模可控，脚本已模板化。</a:t>
+              <a:defRPr sz="1000"/>
+            </a:pPr>
+            <a:r>
+              <a:t>写回已降级为 guardrail，不作为独立实验阶段。多模态泛化验证在文本 RC1+RC2 消融完成后启动。</a:t>
             </a:r>
           </a:p>
         </p:txBody>
@@ -12738,7 +12738,7 @@
               </a:defRPr>
             </a:pPr>
             <a:r>
-              <a:t>第四阶段</a:t>
+              <a:t>补充阶段</a:t>
             </a:r>
           </a:p>
         </p:txBody>
@@ -12810,7 +12810,7 @@
               </a:defRPr>
             </a:pPr>
             <a:r>
-              <a:t>写回判定</a:t>
+              <a:t>多模态泛化验证</a:t>
             </a:r>
           </a:p>
           <a:p>
@@ -12822,9 +12822,6 @@
                 <a:latin typeface="微软雅黑" panose="020B0503020204020204" charset="-122"/>
               </a:defRPr>
             </a:pPr>
-            <a:r>
-              <a:t>Sink对比</a:t>
-            </a:r>
           </a:p>
           <a:p>
             <a:pPr algn="ctr">
@@ -12835,8 +12832,31 @@
                 <a:latin typeface="微软雅黑" panose="020B0503020204020204" charset="-122"/>
               </a:defRPr>
             </a:pPr>
-            <a:r>
-              <a:t>保护约束</a:t>
+          </a:p>
+          <a:p>
+            <a:pPr algn="l">
+              <a:defRPr sz="1000">
+                <a:solidFill>
+                  <a:srgbClr val="000000"/>
+                </a:solidFill>
+                <a:latin typeface="Microsoft YaHei"/>
+              </a:defRPr>
+            </a:pPr>
+            <a:r>
+              <a:t>写回 guardrail</a:t>
+            </a:r>
+          </a:p>
+          <a:p>
+            <a:pPr algn="l">
+              <a:defRPr sz="1000">
+                <a:solidFill>
+                  <a:srgbClr val="000000"/>
+                </a:solidFill>
+                <a:latin typeface="Microsoft YaHei"/>
+              </a:defRPr>
+            </a:pPr>
+            <a:r>
+              <a:t>算子代价估计</a:t>
             </a:r>
           </a:p>
         </p:txBody>

</xml_diff>